<commit_message>
Transforma a proposta em guia da aula pratica para as equipes
- Proposta reescrita como guia do aluno: primeiro acesso com MFA,
  passo a passo por parte, pagina de cada equipe e checklist de entrega
- Remove do repositorio o guia de preparacao do instrutor
- Roteiro, README e guias descrevem o que ja vem pronto no projeto
- Slides publicos sem notas do apresentador

Co-Authored-By: Claude Opus 5.5 <noreply@anthropic.com>
</commit_message>
<xml_diff>
--- a/slides/Apresentacao_Azure_DevOps_2026-09-29.pptx
+++ b/slides/Apresentacao_Azure_DevOps_2026-09-29.pptx
@@ -1112,7 +1112,7 @@
           <a:p>
             <a:r>
               <a:rPr lang="en-US" dirty="0"/>
-              <a:t>CMMI: Change Request NÃO fica entre Requirement e Task. A hierarquia é Epic &gt; Feature &gt; Requirement &gt; Task; Change Request, Risk, Review e Issue são itens que se relacionam ao Requirement.</a:t>
+              <a:t/>
             </a:r>
             <a:endParaRPr lang="en-US" dirty="0"/>
           </a:p>
@@ -1816,7 +1816,7 @@
           <a:p>
             <a:r>
               <a:rPr lang="en-US" dirty="0"/>
-              <a:t>Usar o projeto de demonstração já preenchido para mostrar burndown e dashboard com dados (o burndown depende de dias de histórico).</a:t>
+              <a:t/>
             </a:r>
             <a:endParaRPr lang="en-US" dirty="0"/>
           </a:p>
@@ -1904,7 +1904,7 @@
           <a:p>
             <a:r>
               <a:rPr lang="en-US" dirty="0"/>
-              <a:t>Correção em relação à versão anterior: o crédito do Azure for Students é de US$ 100 (não R$ 500) e não é necessário para usar o Azure DevOps. Alunos entram com acesso Basic somente hoje.</a:t>
+              <a:t/>
             </a:r>
             <a:endParaRPr lang="en-US" dirty="0"/>
           </a:p>
@@ -2168,7 +2168,7 @@
           <a:p>
             <a:r>
               <a:rPr lang="en-US" dirty="0"/>
-              <a:t>Primeira tarefa de cada equipe: escolher o Gerente do Projeto (conduz priorização e Sprint).</a:t>
+              <a:t/>
             </a:r>
             <a:endParaRPr lang="en-US" dirty="0"/>
           </a:p>
@@ -2344,7 +2344,7 @@
           <a:p>
             <a:r>
               <a:rPr lang="en-US" dirty="0"/>
-              <a:t>Papéis sugeridos (6 por equipe): Gerente do projeto, Product Owner, Guardião do backlog, Guardião do board, Analista de indicadores, Responsável pela entrega.</a:t>
+              <a:t/>
             </a:r>
             <a:endParaRPr lang="en-US" dirty="0"/>
           </a:p>
@@ -2696,7 +2696,7 @@
           <a:p>
             <a:r>
               <a:rPr lang="en-US" dirty="0"/>
-              <a:t>O cronograma do guia do instrutor fecha exatamente em 4h. Se houver intervalo, reduzir Refinamento e Board para 20 min cada.</a:t>
+              <a:t/>
             </a:r>
             <a:endParaRPr lang="en-US" dirty="0"/>
           </a:p>
@@ -11129,7 +11129,7 @@
                 <a:ea typeface="Calibri" pitchFamily="34" charset="-122"/>
                 <a:cs typeface="Calibri" pitchFamily="34" charset="-120"/>
               </a:rPr>
-              <a:t>Nada de criar conta ou organização: o professor já preparou tudo</a:t>
+              <a:t>Contas, equipes e projetos já foram preparados pelo professor</a:t>
             </a:r>
             <a:endParaRPr lang="en-US" sz="1300" dirty="0"/>
           </a:p>
@@ -11244,7 +11244,7 @@
                 <a:ea typeface="Calibri" pitchFamily="34" charset="-122"/>
                 <a:cs typeface="Calibri" pitchFamily="34" charset="-120"/>
               </a:rPr>
-              <a:t>1. Convite</a:t>
+              <a:t>1. Acesse</a:t>
             </a:r>
             <a:endParaRPr lang="en-US" sz="1400" dirty="0"/>
           </a:p>
@@ -11283,7 +11283,7 @@
                 <a:ea typeface="Calibri" pitchFamily="34" charset="-122"/>
                 <a:cs typeface="Calibri" pitchFamily="34" charset="-120"/>
               </a:rPr>
-              <a:t>Abra o e-mail “You've been invited to Azure DevOps” e clique em Join now.</a:t>
+              <a:t>dev.azure.com/unifor-mba-gp-2026</a:t>
             </a:r>
             <a:endParaRPr lang="en-US" sz="1100" dirty="0"/>
           </a:p>
@@ -11462,7 +11462,7 @@
                 <a:ea typeface="Calibri" pitchFamily="34" charset="-122"/>
                 <a:cs typeface="Calibri" pitchFamily="34" charset="-120"/>
               </a:rPr>
-              <a:t>Entre com o mesmo e-mail que recebeu o convite.</a:t>
+              <a:t>nome.sobrenome@arijrtechnology.com.br e a senha da planilha (troque no 1º acesso).</a:t>
             </a:r>
             <a:endParaRPr lang="en-US" sz="1100" dirty="0"/>
           </a:p>
@@ -13729,7 +13729,7 @@
                 <a:ea typeface="Calibri" pitchFamily="34" charset="-122"/>
                 <a:cs typeface="Calibri" pitchFamily="34" charset="-120"/>
               </a:rPr>
-              <a:t>Composição informada pelo professor em sala</a:t>
+              <a:t>Composição enviada no grupo da turma</a:t>
             </a:r>
             <a:endParaRPr lang="en-US" sz="1100" dirty="0"/>
           </a:p>
@@ -13884,7 +13884,7 @@
                 <a:ea typeface="Calibri" pitchFamily="34" charset="-122"/>
                 <a:cs typeface="Calibri" pitchFamily="34" charset="-120"/>
               </a:rPr>
-              <a:t>Composição informada pelo professor em sala</a:t>
+              <a:t>Composição enviada no grupo da turma</a:t>
             </a:r>
             <a:endParaRPr lang="en-US" sz="1100" dirty="0"/>
           </a:p>
@@ -14039,7 +14039,7 @@
                 <a:ea typeface="Calibri" pitchFamily="34" charset="-122"/>
                 <a:cs typeface="Calibri" pitchFamily="34" charset="-120"/>
               </a:rPr>
-              <a:t>Composição informada pelo professor em sala</a:t>
+              <a:t>Composição enviada no grupo da turma</a:t>
             </a:r>
             <a:endParaRPr lang="en-US" sz="1100" dirty="0"/>
           </a:p>
@@ -14194,7 +14194,7 @@
                 <a:ea typeface="Calibri" pitchFamily="34" charset="-122"/>
                 <a:cs typeface="Calibri" pitchFamily="34" charset="-120"/>
               </a:rPr>
-              <a:t>Composição informada pelo professor em sala</a:t>
+              <a:t>Composição enviada no grupo da turma</a:t>
             </a:r>
             <a:endParaRPr lang="en-US" sz="1100" dirty="0"/>
           </a:p>
@@ -18982,7 +18982,7 @@
                 <a:ea typeface="Calibri" pitchFamily="34" charset="-122"/>
                 <a:cs typeface="Calibri" pitchFamily="34" charset="-120"/>
               </a:rPr>
-              <a:t>Convite, projeto da equipe e primeira pipeline</a:t>
+              <a:t>Login, projeto da equipe e primeira pipeline</a:t>
             </a:r>
             <a:endParaRPr lang="en-US" sz="1000" dirty="0"/>
           </a:p>

</xml_diff>